<commit_message>
M3: accept M1's merged config in installer; re-run baseline under M4 memory
install.py reports M1-owned files that keep every M3 edit as merged (M1
merged M4 memory and M5 exploration into m1_integrated.yaml). The ablation
runner re-runs m1_baseline by default, since M1's recorded baseline predates
M4 memory, checks M4 is installed and sets a unique M4_RUN_ID per run. The
summarizer pairs only same-configuration baselines and lists M1's recorded
runs for context. Docs, method text and slide notes updated; 12 M3 tool
tests pass.
</commit_message>
<xml_diff>
--- a/M3/report/M3_Method_Draft.pptx
+++ b/M3/report/M3_Method_Draft.pptx
@@ -109,13 +109,13 @@
   <p:extLst>
     <p:ext uri="{521415D9-36F7-43E2-AB2F-B90AF26B5E84}">
       <p14:sectionLst xmlns:p14="http://schemas.microsoft.com/office/powerpoint/2010/main">
-        <p14:section name="Method" id="{e6403c03-d2ab-9761-d8d0-89f191b72f6d}">
+        <p14:section name="Method" id="{1c9e9ce5-0399-8b4a-03f9-6b00c394e0b5}">
           <p14:sldIdLst>
             <p14:sldId id="256"/>
             <p14:sldId id="257"/>
           </p14:sldIdLst>
         </p14:section>
-        <p14:section name="Evaluation" id="{45239ec6-7b5c-9bd0-deb8-9f9d9a0d98c2}">
+        <p14:section name="Evaluation" id="{8bad32d9-36a5-cb4f-0f34-0759b88c83af}">
           <p14:sldIdLst>
             <p14:sldId id="258"/>
           </p14:sldIdLst>
@@ -700,7 +700,7 @@
           <a:p>
             <a:r>
               <a:rPr lang="en-US" dirty="0"/>
-              <a:t>We measure M3 against M1's reference agent, which already ran on all six development systems and three seeds and found 5 stable, unique, novel structures per run on average, with a wide spread. M3 adds three configurations on exactly the same systems, seeds, budget and oracle: full M3, M3 with planning off, and M3 with self-correction off. Each is paired with the reference by system and seed. The difference between full M3 and each ablation isolates what planning and self-correction contribute. Those 54 runs happen on the 26th and 27th; this slide will then show the paired differences and one or two traced re-plan cases. No result is claimed yet.</a:t>
+              <a:t>We measure M3 against M1's reference agent. In its first runs on all six development systems and three seeds, it found 5 stable, unique, novel structures per run on average, with a wide spread. Since then the team added M4's memory, so I re-run the reference under the same setup as M3. M3 adds three configurations on exactly the same systems, seeds, budget and oracle: full M3, M3 with planning off, and M3 with self-correction off. Each is paired with the re-run reference by system and seed. The difference between full M3 and each ablation isolates what planning and self-correction contribute. Those runs happen on the 26th and 27th. This slide will then show the paired differences and one or two traced re-plan cases. No result is claimed yet.</a:t>
             </a:r>
             <a:endParaRPr lang="en-US" dirty="0"/>
           </a:p>

</xml_diff>

<commit_message>
M3: fixed-code dev ablations (72 runs), results, slide 3, evidence
All 72 runs (m1_baseline + m3_full + m3_planning_off +
m3_self_correction_off, 6 dev systems x seeds 17/29/43) re-run on one
machine with the progress-signal fix; all completed on the first attempt.
The re-run baseline matches M1's 19 Oct values in all 18 pairs.

- results/*.csv and report/M3_RESULTS.md regenerated; "Why" written:
  m3_full +1.50 mSUN vs reference (9/3/6), planning +1.39 (12/1/5),
  self-correction +0.67 (7/10/1). M3 lifts weak systems and loses on
  strong ones because the planner commits to binary edges.
- Slide 3 and speaker notes show the results.
- evidence/20261021-dev-ablations/: run index, M3 trace lines, sweep log,
  traced Co-Mg-Na seed 17 case.
- README, HANDOVER and report/README status updated.
</commit_message>
<xml_diff>
--- a/M3/report/M3_Method_Draft.pptx
+++ b/M3/report/M3_Method_Draft.pptx
@@ -699,10 +699,8 @@
           <a:lstStyle/>
           <a:p>
             <a:r>
-              <a:rPr lang="en-US" dirty="0"/>
-              <a:t>We measure M3 against M1's reference agent. In its first runs on all six development systems and three seeds, it found 5 stable, unique, novel structures per run on average, with a wide spread. Since then the team added M4's memory, so I re-run the reference under the same setup as M3. M3 adds three configurations on exactly the same systems, seeds, budget and oracle: full M3, M3 with planning off, and M3 with self-correction off. Each is paired with the re-run reference by system and seed. The difference between full M3 and each ablation isolates what planning and self-correction contribute. Those runs happen on the 26th and 27th. This slide will then show the paired differences and one or two traced re-plan cases. No result is claimed yet.</a:t>
-            </a:r>
-            <a:endParaRPr lang="en-US" dirty="0"/>
+              <a:t>All 72 runs finished. The re-run reference matches M1's recorded numbers exactly, so the comparison is clean. Full M3 finds 1.5 more stable, unique, novel structures per run than the reference, but the spread is larger than the mean, and the effect depends on the system. On the three systems where the reference finds almost nothing, M3 goes from about 1 to about 7. On the three where the reference already does well, M3 drops from about 9 to about 6. The reason is the planner: it commits to binary edges and gives the ternary interior at most two of its five batches. That pays off when the stable phases sit on an edge, like gold-terbium, and costs discoveries in hafnium-nickel-zirconium, where the interior is rich. Planning adds 1.4 over planning off. Self-correction adds 0.7: it re-planned 16 times, all for no progress, and the clearest case is cobalt-magnesium-sodium, where re-plans at queries 6 and 13 lift the three seeds from 3 structures in total to 13. Next step: keep a minimum share of queries for the ternary interior.</a:t>
+            </a:r>
           </a:p>
         </p:txBody>
       </p:sp>
@@ -3333,7 +3331,7 @@
                   <a:schemeClr val="tx2"/>
                 </a:solidFill>
               </a:rPr>
-              <a:t>Two ablations against M1's reference</a:t>
+              <a:t>M3 lifts weak systems, loses on strong ones</a:t>
             </a:r>
             <a:endParaRPr lang="en-US" sz="2800" dirty="0"/>
           </a:p>
@@ -3565,7 +3563,7 @@
                             <a:schemeClr val="bg1"/>
                           </a:solidFill>
                         </a:rPr>
-                        <a:t>Role</a:t>
+                        <a:t>mSUN@20</a:t>
                       </a:r>
                       <a:endParaRPr lang="en-US" sz="1200" dirty="0"/>
                     </a:p>
@@ -3811,7 +3809,7 @@
                             <a:schemeClr val="tx1"/>
                           </a:solidFill>
                         </a:rPr>
-                        <a:t>Reference (done)</a:t>
+                        <a:t>5.0 ± 4.4</a:t>
                       </a:r>
                       <a:endParaRPr lang="en-US" sz="1200" dirty="0"/>
                     </a:p>
@@ -4057,7 +4055,7 @@
                             <a:schemeClr val="tx1"/>
                           </a:solidFill>
                         </a:rPr>
-                        <a:t>Full M3</a:t>
+                        <a:t>6.5 ± 2.6</a:t>
                       </a:r>
                       <a:endParaRPr lang="en-US" sz="1200" dirty="0"/>
                     </a:p>
@@ -4303,7 +4301,7 @@
                             <a:schemeClr val="tx1"/>
                           </a:solidFill>
                         </a:rPr>
-                        <a:t>Planning ablation</a:t>
+                        <a:t>5.1 ± 3.0</a:t>
                       </a:r>
                       <a:endParaRPr lang="en-US" sz="1200" dirty="0"/>
                     </a:p>
@@ -4549,7 +4547,7 @@
                             <a:schemeClr val="tx1"/>
                           </a:solidFill>
                         </a:rPr>
-                        <a:t>Self-corr. ablation</a:t>
+                        <a:t>5.8 ± 3.1</a:t>
                       </a:r>
                       <a:endParaRPr lang="en-US" sz="1200" dirty="0"/>
                     </a:p>
@@ -4631,7 +4629,7 @@
                   <a:schemeClr val="tx1"/>
                 </a:solidFill>
               </a:rPr>
-              <a:t>Same 6 dev systems, seeds 17/29/43, 20 queries, ORB v3 oracle. Paired by system and seed; primary metric mSUN@20, plus AUDC, AF, EF.</a:t>
+              <a:t>72 of 72 runs completed: 6 dev systems, seeds 17/29/43, 20 queries, ORB v3 oracle, M4 memory on in every arm. Paired by system and seed; the re-run reference matches M1's recorded runs in all 18 pairs.</a:t>
             </a:r>
             <a:endParaRPr lang="en-US" sz="1200" dirty="0"/>
           </a:p>
@@ -4694,7 +4692,7 @@
                   <a:schemeClr val="accent1"/>
                 </a:solidFill>
               </a:rPr>
-              <a:t>5.0</a:t>
+              <a:t>+1.5</a:t>
             </a:r>
             <a:endParaRPr lang="en-US" sz="5400" dirty="0"/>
           </a:p>
@@ -4730,7 +4728,7 @@
                   <a:schemeClr val="tx1"/>
                 </a:solidFill>
               </a:rPr>
-              <a:t>mean mSUN@20 of M1's reference</a:t>
+              <a:t>mSUN@20 per run vs reference</a:t>
             </a:r>
             <a:endParaRPr lang="en-US" sz="1200" dirty="0"/>
           </a:p>
@@ -4744,7 +4742,7 @@
                   <a:schemeClr val="tx1"/>
                 </a:solidFill>
               </a:rPr>
-              <a:t>± 4.4 over 18 runs</a:t>
+              <a:t>9 better, 3 same, 6 worse</a:t>
             </a:r>
             <a:endParaRPr lang="en-US" sz="1200" dirty="0"/>
           </a:p>
@@ -4780,7 +4778,21 @@
                   <a:schemeClr val="accent3"/>
                 </a:solidFill>
               </a:rPr>
-              <a:t>M3 results: 54 runs, 26–27 Oct</a:t>
+              <a:t>Weak systems 1.1 → 6.7</a:t>
+            </a:r>
+            <a:endParaRPr lang="en-US" sz="1400" dirty="0"/>
+          </a:p>
+          <a:p>
+            <a:pPr algn="ctr" indent="0" marL="0">
+              <a:buNone/>
+            </a:pPr>
+            <a:r>
+              <a:rPr lang="en-US" sz="1400" b="1" dirty="0">
+                <a:solidFill>
+                  <a:schemeClr val="accent3"/>
+                </a:solidFill>
+              </a:rPr>
+              <a:t>Strong systems 8.9 → 6.3</a:t>
             </a:r>
             <a:endParaRPr lang="en-US" sz="1400" dirty="0"/>
           </a:p>
@@ -4828,6 +4840,42 @@
               <a:t>3</a:t>
             </a:fld>
             <a:endParaRPr lang="en-US"/>
+          </a:p>
+        </p:txBody>
+      </p:sp>
+      <p:sp>
+        <p:nvSpPr>
+          <p:cNvPr id="26" name="ablation effects"/>
+          <p:cNvSpPr txBox="1"/>
+          <p:nvPr/>
+        </p:nvSpPr>
+        <p:spPr>
+          <a:xfrm>
+            <a:off x="457200" y="4069080"/>
+            <a:ext cx="5120640" cy="548640"/>
+          </a:xfrm>
+          <a:prstGeom prst="rect">
+            <a:avLst/>
+          </a:prstGeom>
+          <a:noFill/>
+          <a:ln/>
+        </p:spPr>
+        <p:txBody>
+          <a:bodyPr wrap="square" lIns="0" tIns="0" rIns="0" bIns="0" rtlCol="0" anchor="ctr"/>
+          <a:lstStyle/>
+          <a:p>
+            <a:pPr indent="0" marL="0">
+              <a:buNone/>
+            </a:pPr>
+            <a:r>
+              <a:rPr lang="en-US" sz="1200" dirty="0">
+                <a:solidFill>
+                  <a:schemeClr val="tx1"/>
+                </a:solidFill>
+              </a:rPr>
+              <a:t>Planning: +1.4 vs planning off (better/same/worse 12/1/5). Self-correction: +0.7 vs off (7/10/1); 16 re-plans, all for no progress.</a:t>
+            </a:r>
+            <a:endParaRPr lang="en-US" sz="1200" dirty="0"/>
           </a:p>
         </p:txBody>
       </p:sp>

</xml_diff>

<commit_message>
M3: plain-language slides and speaker notes
Rewrite slide text and notes for all three slides without jargon (tries, areas, recipes); add a Q&A cheat sheet to M3_SPEAKER_NOTES.md. Numbers unchanged; demo re-checked with the fixed code.
</commit_message>
<xml_diff>
--- a/M3/report/M3_Method_Draft.pptx
+++ b/M3/report/M3_Method_Draft.pptx
@@ -523,10 +523,8 @@
           <a:lstStyle/>
           <a:p>
             <a:r>
-              <a:rPr lang="en-US" dirty="0"/>
-              <a:t>M3 decides where the agent spends its 20 oracle queries. I split a chemical system into sub-goals, one per subset of its elements, so a ternary has three binary edges and the ternary interior. The planner works in batches of four queries on one sub-goal, choosing the least-tried, most novel compositions that pass the charge-balance check. After each batch it reviews every sub-goal: smoothed success rate from what it has observed, plus memory from M4 when that is on, plus a bonus for unexplored compositions. The best sub-goal becomes the next target. It uses no language model, so it adds no API cost, and it never sees hidden labels.</a:t>
-            </a:r>
-            <a:endParaRPr lang="en-US" dirty="0"/>
+              <a:t>Our agent only gets 20 tries to find new materials, so my first part decides where those tries go. Each search uses three elements, for example magnesium, tin and strontium. A new material can combine any two of them, or all three. So I split the search into four areas: the three pairs, and the three-element mix. The agent spends four tries at a time in one area. Within that area, it picks recipes it hasn't tried yet, choosing ones that are as different as possible from earlier tries, and skips recipes that fail a basic chemistry check. After every four tries, it compares the areas: how many stable materials each has produced, what our shared memory says, and how much is still untried. It then moves to the most promising area. It's a set of simple rules, not an AI model, so it costs nothing to run, and it never looks at the answers.</a:t>
+            </a:r>
           </a:p>
         </p:txBody>
       </p:sp>
@@ -611,10 +609,8 @@
           <a:lstStyle/>
           <a:p>
             <a:r>
-              <a:rPr lang="en-US" dirty="0"/>
-              <a:t>The second part checks every plan before it is used. It declares the search stuck if six queries in a row found nothing new, or if the plan would repeat a formula already tried twice. Then it swaps in compositions that have been visited least and are farthest from what we just tried. If the stall continues, it widens generation; that costs no extra oracle queries, and M1 still caps the plan at the remaining budget. In this scripted demo on lithium-iron-oxygen, new phases appear only at queries 3 and 13, and self-correction re-plans three times in the dry stretch between them. Every re-plan is logged, so in the real runs we can trace which discoveries followed a re-plan.</a:t>
-            </a:r>
-            <a:endParaRPr lang="en-US" dirty="0"/>
+              <a:t>My second part checks the plan before every try, looking for two signs that the search is stuck: six tries in a row with no new stable material, or a plan to repeat a recipe that's already been tried twice. When either happens, it changes course. It swaps in the recipes that have been tried least and are most different from the recent ones. If the search stays stuck, it also generates more candidate structures for each recipe. That doesn't use up any of the 20 tries. This small demo shows the idea with made-up results: finds only at tries 3 and 13. In the empty stretch between them, the agent changed course three times. Every change of course is recorded, so in the real runs we can see what happened after each one.</a:t>
+            </a:r>
           </a:p>
         </p:txBody>
       </p:sp>
@@ -699,7 +695,7 @@
           <a:lstStyle/>
           <a:p>
             <a:r>
-              <a:t>All 72 runs finished. The re-run reference matches M1's recorded numbers exactly, so the comparison is clean. Full M3 finds 1.5 more stable, unique, novel structures per run than the reference, but the spread is larger than the mean, and the effect depends on the system. On the three systems where the reference finds almost nothing, M3 goes from about 1 to about 7. On the three where the reference already does well, M3 drops from about 9 to about 6. The reason is the planner: it commits to binary edges and gives the ternary interior at most two of its five batches. That pays off when the stable phases sit on an edge, like gold-terbium, and costs discoveries in hafnium-nickel-zirconium, where the interior is rich. Planning adds 1.4 over planning off. Self-correction adds 0.7: it re-planned 16 times, all for no progress, and the clearest case is cobalt-magnesium-sodium, where re-plans at queries 6 and 13 lift the three seeds from 3 structures in total to 13. Next step: keep a minimum share of queries for the ternary interior.</a:t>
+              <a:t>We ran 72 tests: six practice systems, three repeats each, with and without each part. The reference agent reproduced its earlier numbers exactly, so the comparison is fair. With both of my parts on, the agent found 1.5 more new stable materials per run than the reference: 6.5 instead of 5. But this depends heavily on the system. On the three hard systems, where the reference found almost nothing, it went from about 1 to about 7. On the three easy ones, it dropped from about 9 to about 6. The reason is that my planner mostly stays with the pairs and rarely tries all three elements together. That works when the good materials are in a pair, like gold-potassium-terbium, but misses them in hafnium-nickel-zirconium, where most are in the three-element mix. Planning adds about 1.4 materials per run, and self-correction about 0.7. The clearest case is cobalt-magnesium-sodium: changing course after six empty tries raised the total from 3 to 13 across its three runs. Next step: always save some tries for the three-element mix.</a:t>
             </a:r>
           </a:p>
         </p:txBody>
@@ -1294,7 +1290,7 @@
                   <a:schemeClr val="tx2"/>
                 </a:solidFill>
               </a:rPr>
-              <a:t>Plan in sub-goals, review after every batch</a:t>
+              <a:t>Plan the search in parts</a:t>
             </a:r>
             <a:endParaRPr lang="en-US" sz="2800" dirty="0"/>
           </a:p>
@@ -1465,7 +1461,7 @@
                   <a:schemeClr val="tx2"/>
                 </a:solidFill>
               </a:rPr>
-              <a:t>A-B-C interior</a:t>
+              <a:t>All three mixed</a:t>
             </a:r>
             <a:endParaRPr lang="en-US" sz="1200" dirty="0"/>
           </a:p>
@@ -1501,7 +1497,7 @@
                   <a:schemeClr val="tx1"/>
                 </a:solidFill>
               </a:rPr>
-              <a:t>Sub-goals = element subsets</a:t>
+              <a:t>4 search areas:</a:t>
             </a:r>
             <a:endParaRPr lang="en-US" sz="1200" dirty="0"/>
           </a:p>
@@ -1515,7 +1511,7 @@
                   <a:schemeClr val="tx1"/>
                 </a:solidFill>
               </a:rPr>
-              <a:t>3 binary edges + 1 ternary interior</a:t>
+              <a:t>3 pairs + the three-element mix</a:t>
             </a:r>
             <a:endParaRPr lang="en-US" sz="1200" dirty="0"/>
           </a:p>
@@ -1639,7 +1635,7 @@
                   <a:schemeClr val="tx2"/>
                 </a:solidFill>
               </a:rPr>
-              <a:t>Plan</a:t>
+              <a:t>Split</a:t>
             </a:r>
             <a:endParaRPr lang="en-US" sz="1500" dirty="0"/>
           </a:p>
@@ -1653,7 +1649,7 @@
                   <a:schemeClr val="tx1"/>
                 </a:solidFill>
               </a:rPr>
-              <a:t>Split the system into sub-goals</a:t>
+              <a:t>Divide the search into 4 areas</a:t>
             </a:r>
             <a:endParaRPr lang="en-US" sz="1500" dirty="0"/>
           </a:p>
@@ -1777,7 +1773,7 @@
                   <a:schemeClr val="tx2"/>
                 </a:solidFill>
               </a:rPr>
-              <a:t>Propose batch</a:t>
+              <a:t>Try</a:t>
             </a:r>
             <a:endParaRPr lang="en-US" sz="1500" dirty="0"/>
           </a:p>
@@ -1791,7 +1787,7 @@
                   <a:schemeClr val="tx1"/>
                 </a:solidFill>
               </a:rPr>
-              <a:t>4 queries on one sub-goal: least-tried, most novel valid compositions</a:t>
+              <a:t>4 tries in one area: untried recipes, unlike earlier ones</a:t>
             </a:r>
             <a:endParaRPr lang="en-US" sz="1500" dirty="0"/>
           </a:p>
@@ -1915,7 +1911,7 @@
                   <a:schemeClr val="tx2"/>
                 </a:solidFill>
               </a:rPr>
-              <a:t>Review</a:t>
+              <a:t>Compare</a:t>
             </a:r>
             <a:endParaRPr lang="en-US" sz="1500" dirty="0"/>
           </a:p>
@@ -1929,7 +1925,7 @@
                   <a:schemeClr val="tx1"/>
                 </a:solidFill>
               </a:rPr>
-              <a:t>Score each sub-goal from observed successes, M4 memory and unexplored share</a:t>
+              <a:t>Score each area: stable finds, memory, how much is untried</a:t>
             </a:r>
             <a:endParaRPr lang="en-US" sz="1500" dirty="0"/>
           </a:p>
@@ -2053,7 +2049,7 @@
                   <a:schemeClr val="tx2"/>
                 </a:solidFill>
               </a:rPr>
-              <a:t>Update plan</a:t>
+              <a:t>Move</a:t>
             </a:r>
             <a:endParaRPr lang="en-US" sz="1500" dirty="0"/>
           </a:p>
@@ -2067,7 +2063,7 @@
                   <a:schemeClr val="tx1"/>
                 </a:solidFill>
               </a:rPr>
-              <a:t>Best-scoring sub-goal becomes the next target</a:t>
+              <a:t>Go to the most promising area next</a:t>
             </a:r>
             <a:endParaRPr lang="en-US" sz="1500" dirty="0"/>
           </a:p>
@@ -2175,7 +2171,7 @@
                   <a:schemeClr val="tx2"/>
                 </a:solidFill>
               </a:rPr>
-              <a:t>Detect a stalled search and re-plan</a:t>
+              <a:t>Notice when the search is stuck</a:t>
             </a:r>
             <a:endParaRPr lang="en-US" sz="2800" dirty="0"/>
           </a:p>
@@ -2252,7 +2248,7 @@
                   <a:schemeClr val="tx1"/>
                 </a:solidFill>
               </a:rPr>
-              <a:t>No new phase in the last 6 queries</a:t>
+              <a:t>6 tries in a row with no new stable material</a:t>
             </a:r>
             <a:endParaRPr lang="en-US" sz="1500" dirty="0"/>
           </a:p>
@@ -2315,7 +2311,7 @@
                   <a:schemeClr val="accent3"/>
                 </a:solidFill>
               </a:rPr>
-              <a:t>Repetition</a:t>
+              <a:t>Repeating</a:t>
             </a:r>
             <a:endParaRPr lang="en-US" sz="1500" dirty="0"/>
           </a:p>
@@ -2329,7 +2325,7 @@
                   <a:schemeClr val="tx1"/>
                 </a:solidFill>
               </a:rPr>
-              <a:t>Plan repeats a formula already tried twice</a:t>
+              <a:t>Plan repeats a recipe already tried twice</a:t>
             </a:r>
             <a:endParaRPr lang="en-US" sz="1500" dirty="0"/>
           </a:p>
@@ -2395,7 +2391,7 @@
                   <a:schemeClr val="bg1"/>
                 </a:solidFill>
               </a:rPr>
-              <a:t>Re-plan</a:t>
+              <a:t>Change course</a:t>
             </a:r>
             <a:endParaRPr lang="en-US" sz="1500" dirty="0"/>
           </a:p>
@@ -2413,7 +2409,7 @@
                   <a:schemeClr val="bg1"/>
                 </a:solidFill>
               </a:rPr>
-              <a:t>Least-visited compositions farthest from recent queries</a:t>
+              <a:t>Swap in the least-tried recipes, unlike recent ones</a:t>
             </a:r>
             <a:endParaRPr lang="en-US" sz="1500" dirty="0"/>
           </a:p>
@@ -2431,7 +2427,7 @@
                   <a:schemeClr val="bg1"/>
                 </a:solidFill>
               </a:rPr>
-              <a:t>Repeated stalls double candidates per composition</a:t>
+              <a:t>Still stuck: make more candidates (no extra tries)</a:t>
             </a:r>
             <a:endParaRPr lang="en-US" sz="1500" dirty="0"/>
           </a:p>
@@ -2449,7 +2445,7 @@
                   <a:schemeClr val="bg1"/>
                 </a:solidFill>
               </a:rPr>
-              <a:t>3-query cooldown; a discovery resets it</a:t>
+              <a:t>Waits 3 tries between changes; a find resets it</a:t>
             </a:r>
             <a:endParaRPr lang="en-US" sz="1500" dirty="0"/>
           </a:p>
@@ -2485,7 +2481,7 @@
                   <a:schemeClr val="tx2"/>
                 </a:solidFill>
               </a:rPr>
-              <a:t>Synthetic demo, Li-Fe-O, 16 queries</a:t>
+              <a:t>Demo with made-up results: Li-Fe-O, 16 tries</a:t>
             </a:r>
             <a:endParaRPr lang="en-US" sz="1400" dirty="0"/>
           </a:p>
@@ -3126,7 +3122,7 @@
                   <a:schemeClr val="tx1"/>
                 </a:solidFill>
               </a:rPr>
-              <a:t>New phase found (queries 3, 13)</a:t>
+              <a:t>New stable material (tries 3, 13)</a:t>
             </a:r>
             <a:endParaRPr lang="en-US" sz="1200" dirty="0"/>
           </a:p>
@@ -3187,7 +3183,7 @@
                   <a:schemeClr val="tx1"/>
                 </a:solidFill>
               </a:rPr>
-              <a:t>Self-correction re-planned (queries 8, 10, 12)</a:t>
+              <a:t>Changed course (tries 8, 10, 12)</a:t>
             </a:r>
             <a:endParaRPr lang="en-US" sz="1200" dirty="0"/>
           </a:p>
@@ -3223,7 +3219,7 @@
                   <a:schemeClr val="accent5"/>
                 </a:solidFill>
               </a:rPr>
-              <a:t>Scripted feedback: shows the mechanism, not performance.</a:t>
+              <a:t>Made-up results: shows how it works, not how well.</a:t>
             </a:r>
             <a:endParaRPr lang="en-US" sz="1100" dirty="0"/>
           </a:p>
@@ -3331,7 +3327,7 @@
                   <a:schemeClr val="tx2"/>
                 </a:solidFill>
               </a:rPr>
-              <a:t>M3 lifts weak systems, loses on strong ones</a:t>
+              <a:t>Better on hard systems, worse on easy ones</a:t>
             </a:r>
             <a:endParaRPr lang="en-US" sz="2800" dirty="0"/>
           </a:p>
@@ -3380,7 +3376,7 @@
                             <a:schemeClr val="bg1"/>
                           </a:solidFill>
                         </a:rPr>
-                        <a:t>Run</a:t>
+                        <a:t>Version</a:t>
                       </a:r>
                       <a:endParaRPr lang="en-US" sz="1200" dirty="0"/>
                     </a:p>
@@ -3563,7 +3559,7 @@
                             <a:schemeClr val="bg1"/>
                           </a:solidFill>
                         </a:rPr>
-                        <a:t>mSUN@20</a:t>
+                        <a:t>Found / run</a:t>
                       </a:r>
                       <a:endParaRPr lang="en-US" sz="1200" dirty="0"/>
                     </a:p>
@@ -3626,7 +3622,7 @@
                             <a:schemeClr val="tx1"/>
                           </a:solidFill>
                         </a:rPr>
-                        <a:t>m1_baseline</a:t>
+                        <a:t>Reference (M1)</a:t>
                       </a:r>
                       <a:endParaRPr lang="en-US" sz="1200" dirty="0"/>
                     </a:p>
@@ -3687,7 +3683,7 @@
                             <a:schemeClr val="tx1"/>
                           </a:solidFill>
                         </a:rPr>
-                        <a:t>diversity</a:t>
+                        <a:t>M1's own</a:t>
                       </a:r>
                       <a:endParaRPr lang="en-US" sz="1200" dirty="0"/>
                     </a:p>
@@ -3809,7 +3805,7 @@
                             <a:schemeClr val="tx1"/>
                           </a:solidFill>
                         </a:rPr>
-                        <a:t>5.0 ± 4.4</a:t>
+                        <a:t>5.0</a:t>
                       </a:r>
                       <a:endParaRPr lang="en-US" sz="1200" dirty="0"/>
                     </a:p>
@@ -3872,7 +3868,7 @@
                             <a:schemeClr val="tx1"/>
                           </a:solidFill>
                         </a:rPr>
-                        <a:t>m3_full</a:t>
+                        <a:t>M3 full</a:t>
                       </a:r>
                       <a:endParaRPr lang="en-US" sz="1200" dirty="0"/>
                     </a:p>
@@ -4055,7 +4051,7 @@
                             <a:schemeClr val="tx1"/>
                           </a:solidFill>
                         </a:rPr>
-                        <a:t>6.5 ± 2.6</a:t>
+                        <a:t>6.5</a:t>
                       </a:r>
                       <a:endParaRPr lang="en-US" sz="1200" dirty="0"/>
                     </a:p>
@@ -4118,7 +4114,7 @@
                             <a:schemeClr val="tx1"/>
                           </a:solidFill>
                         </a:rPr>
-                        <a:t>m3_planning_off</a:t>
+                        <a:t>Planning off</a:t>
                       </a:r>
                       <a:endParaRPr lang="en-US" sz="1200" dirty="0"/>
                     </a:p>
@@ -4301,7 +4297,7 @@
                             <a:schemeClr val="tx1"/>
                           </a:solidFill>
                         </a:rPr>
-                        <a:t>5.1 ± 3.0</a:t>
+                        <a:t>5.1</a:t>
                       </a:r>
                       <a:endParaRPr lang="en-US" sz="1200" dirty="0"/>
                     </a:p>
@@ -4364,7 +4360,7 @@
                             <a:schemeClr val="tx1"/>
                           </a:solidFill>
                         </a:rPr>
-                        <a:t>m3_self_correction_off</a:t>
+                        <a:t>Self-correction off</a:t>
                       </a:r>
                       <a:endParaRPr lang="en-US" sz="1200" dirty="0"/>
                     </a:p>
@@ -4547,7 +4543,7 @@
                             <a:schemeClr val="tx1"/>
                           </a:solidFill>
                         </a:rPr>
-                        <a:t>5.8 ± 3.1</a:t>
+                        <a:t>5.8</a:t>
                       </a:r>
                       <a:endParaRPr lang="en-US" sz="1200" dirty="0"/>
                     </a:p>
@@ -4629,7 +4625,7 @@
                   <a:schemeClr val="tx1"/>
                 </a:solidFill>
               </a:rPr>
-              <a:t>72 of 72 runs completed: 6 dev systems, seeds 17/29/43, 20 queries, ORB v3 oracle, M4 memory on in every arm. Paired by system and seed; the re-run reference matches M1's recorded runs in all 18 pairs.</a:t>
+              <a:t>72 runs: 6 practice systems × 3 repeats × 4 versions, 20 tries each, same simulator and memory for all. The reference matched its earlier numbers exactly, so the comparison is fair.</a:t>
             </a:r>
             <a:endParaRPr lang="en-US" sz="1200" dirty="0"/>
           </a:p>
@@ -4728,7 +4724,7 @@
                   <a:schemeClr val="tx1"/>
                 </a:solidFill>
               </a:rPr>
-              <a:t>mSUN@20 per run vs reference</a:t>
+              <a:t>more finds per run than reference</a:t>
             </a:r>
             <a:endParaRPr lang="en-US" sz="1200" dirty="0"/>
           </a:p>
@@ -4742,7 +4738,7 @@
                   <a:schemeClr val="tx1"/>
                 </a:solidFill>
               </a:rPr>
-              <a:t>9 better, 3 same, 6 worse</a:t>
+              <a:t>better in 9 of 18 runs</a:t>
             </a:r>
             <a:endParaRPr lang="en-US" sz="1200" dirty="0"/>
           </a:p>
@@ -4778,7 +4774,7 @@
                   <a:schemeClr val="accent3"/>
                 </a:solidFill>
               </a:rPr>
-              <a:t>Weak systems 1.1 → 6.7</a:t>
+              <a:t>Hard systems: 1 → 7</a:t>
             </a:r>
             <a:endParaRPr lang="en-US" sz="1400" dirty="0"/>
           </a:p>
@@ -4792,7 +4788,7 @@
                   <a:schemeClr val="accent3"/>
                 </a:solidFill>
               </a:rPr>
-              <a:t>Strong systems 8.9 → 6.3</a:t>
+              <a:t>Easy systems: 9 → 6</a:t>
             </a:r>
             <a:endParaRPr lang="en-US" sz="1400" dirty="0"/>
           </a:p>
@@ -4873,7 +4869,7 @@
                   <a:schemeClr val="tx1"/>
                 </a:solidFill>
               </a:rPr>
-              <a:t>Planning: +1.4 vs planning off (better/same/worse 12/1/5). Self-correction: +0.7 vs off (7/10/1); 16 re-plans, all for no progress.</a:t>
+              <a:t>Planning adds about 1.4 per run, self-correction about 0.7. Cobalt–magnesium–sodium: changing course raised the finds from 3 to 13 across its 3 runs.</a:t>
             </a:r>
             <a:endParaRPr lang="en-US" sz="1200" dirty="0"/>
           </a:p>

</xml_diff>

<commit_message>
M3: tidy docs, add full-agent result to slides, Chemeleon receipt
- Method and design text: progress means a new stable phase; add the
  full-agent ablations to the evaluation design.
- Slide 3 and speaker notes: lead with the full-agent result
  (planning off 10.0 -> 5.3; self-correction off 9.5).
- Runbook: add the frozen-tag and Chemeleon steps for the 90 runs.
- Check record re-run on m1-freeze-20261025 (ae7fe81); same results.
- Run-machine Chemeleon checksum receipt; exact sign-test p = 0.0005.
</commit_message>
<xml_diff>
--- a/M3/report/M3_Method_Draft.pptx
+++ b/M3/report/M3_Method_Draft.pptx
@@ -695,7 +695,7 @@
           <a:lstStyle/>
           <a:p>
             <a:r>
-              <a:t>We ran 72 tests: six practice systems, three repeats each, with and without each part. The reference agent reproduced its earlier numbers exactly, so the comparison is fair. With both of my parts on, the agent found 1.5 more new stable materials per run than the reference: 6.5 instead of 5. But this depends heavily on the system. On the three hard systems, where the reference found almost nothing, it went from about 1 to about 7. On the three easy ones, it dropped from about 9 to about 6. The reason is that my planner mostly stays with the pairs and rarely tries all three elements together. That works when the good materials are in a pair, like gold-potassium-terbium, but misses them in hafnium-nickel-zirconium, where most are in the three-element mix. Planning adds about 1.4 materials per run, and self-correction about 0.7. The clearest case is cobalt-magnesium-sodium: changing course after six empty tries raised the total from 3 to 13 across its three runs. Next step: always save some tries for the three-element mix.</a:t>
+              <a:t>In M1's full frozen agent, with every part on, the agent finds 10 new stable materials per run. Switching off only my planner drops that to 5.3, lower in 15 of 18 paired runs: the largest effect of any part. Switching off only self-correction gives 9.5, with as many runs better as worse, so it shows no clear effect there. The table is my earlier component study, with exploration and tool routing off. There, both my parts together beat the reference by 1.5 per run, and the gain came from the hard systems: about 1 to 7 on the three hard ones, but about 9 to 6 on the three easy ones, because the planner rarely tries all three elements together. Next step: always save some tries for the three-element mix.</a:t>
             </a:r>
           </a:p>
         </p:txBody>
@@ -3327,7 +3327,7 @@
                   <a:schemeClr val="tx2"/>
                 </a:solidFill>
               </a:rPr>
-              <a:t>Better on hard systems, worse on easy ones</a:t>
+              <a:t>Planning matters most in the full agent</a:t>
             </a:r>
             <a:endParaRPr lang="en-US" sz="2800" dirty="0"/>
           </a:p>
@@ -4625,7 +4625,7 @@
                   <a:schemeClr val="tx1"/>
                 </a:solidFill>
               </a:rPr>
-              <a:t>72 runs: 6 practice systems × 3 repeats × 4 versions, 20 tries each, same simulator and memory for all. The reference matched its earlier numbers exactly, so the comparison is fair.</a:t>
+              <a:t>Component study (exploration and routing off): 72 runs, 6 practice systems × 3 repeats × 4 versions, 20 tries each. The reference reproduced exactly.</a:t>
             </a:r>
             <a:endParaRPr lang="en-US" sz="1200" dirty="0"/>
           </a:p>
@@ -4688,7 +4688,7 @@
                   <a:schemeClr val="accent1"/>
                 </a:solidFill>
               </a:rPr>
-              <a:t>+1.5</a:t>
+              <a:t>−4.7</a:t>
             </a:r>
             <a:endParaRPr lang="en-US" sz="5400" dirty="0"/>
           </a:p>
@@ -4724,7 +4724,7 @@
                   <a:schemeClr val="tx1"/>
                 </a:solidFill>
               </a:rPr>
-              <a:t>more finds per run than reference</a:t>
+              <a:t>finds per run without planning</a:t>
             </a:r>
             <a:endParaRPr lang="en-US" sz="1200" dirty="0"/>
           </a:p>
@@ -4738,7 +4738,7 @@
                   <a:schemeClr val="tx1"/>
                 </a:solidFill>
               </a:rPr>
-              <a:t>better in 9 of 18 runs</a:t>
+              <a:t>in the full agent: 10.0 → 5.3</a:t>
             </a:r>
             <a:endParaRPr lang="en-US" sz="1200" dirty="0"/>
           </a:p>
@@ -4774,7 +4774,7 @@
                   <a:schemeClr val="accent3"/>
                 </a:solidFill>
               </a:rPr>
-              <a:t>Hard systems: 1 → 7</a:t>
+              <a:t>Worse in 15 of 18 runs</a:t>
             </a:r>
             <a:endParaRPr lang="en-US" sz="1400" dirty="0"/>
           </a:p>
@@ -4788,7 +4788,7 @@
                   <a:schemeClr val="accent3"/>
                 </a:solidFill>
               </a:rPr>
-              <a:t>Easy systems: 9 → 6</a:t>
+              <a:t>Self-correction off: 9.5, no clear effect</a:t>
             </a:r>
             <a:endParaRPr lang="en-US" sz="1400" dirty="0"/>
           </a:p>
@@ -4869,7 +4869,7 @@
                   <a:schemeClr val="tx1"/>
                 </a:solidFill>
               </a:rPr>
-              <a:t>Planning adds about 1.4 per run, self-correction about 0.7. Cobalt–magnesium–sodium: changing course raised the finds from 3 to 13 across its 3 runs.</a:t>
+              <a:t>Component study: +1.5 per run vs reference (hard systems 1 → 7, easy 9 → 6). Cobalt–magnesium–sodium: changing course raised finds 3 → 13.</a:t>
             </a:r>
             <a:endParaRPr lang="en-US" sz="1200" dirty="0"/>
           </a:p>

</xml_diff>